<commit_message>
docs: update presentation to single-page feature summary
- Re-generated Barista_Recipes_Improvements.pptx as a one-page summary
- Listed all key feature implementations and technical upgrades
- Optimized layout and font size for single-slide readability
</commit_message>
<xml_diff>
--- a/Barista_Recipes_Improvements.pptx
+++ b/Barista_Recipes_Improvements.pptx
@@ -6,14 +6,6 @@
   </p:sldMasterIdLst>
   <p:sldIdLst>
     <p:sldId id="256" r:id="rId7"/>
-    <p:sldId id="257" r:id="rId8"/>
-    <p:sldId id="258" r:id="rId9"/>
-    <p:sldId id="259" r:id="rId10"/>
-    <p:sldId id="260" r:id="rId11"/>
-    <p:sldId id="261" r:id="rId12"/>
-    <p:sldId id="262" r:id="rId13"/>
-    <p:sldId id="263" r:id="rId14"/>
-    <p:sldId id="264" r:id="rId15"/>
   </p:sldIdLst>
   <p:sldSz cx="9144000" cy="6858000" type="screen4x3"/>
   <p:notesSz cx="6858000" cy="9144000"/>
@@ -3103,71 +3095,6 @@
             <a:spLocks noGrp="1"/>
           </p:cNvSpPr>
           <p:nvPr>
-            <p:ph type="ctrTitle"/>
-          </p:nvPr>
-        </p:nvSpPr>
-        <p:spPr/>
-        <p:txBody>
-          <a:bodyPr/>
-          <a:lstStyle/>
-          <a:p>
-            <a:r>
-              <a:t>Barista Recipes Wearable App</a:t>
-            </a:r>
-          </a:p>
-        </p:txBody>
-      </p:sp>
-      <p:sp>
-        <p:nvSpPr>
-          <p:cNvPr id="3" name="Subtitle 2"/>
-          <p:cNvSpPr>
-            <a:spLocks noGrp="1"/>
-          </p:cNvSpPr>
-          <p:nvPr>
-            <p:ph type="subTitle" idx="1"/>
-          </p:nvPr>
-        </p:nvSpPr>
-        <p:spPr/>
-        <p:txBody>
-          <a:bodyPr/>
-          <a:lstStyle/>
-          <a:p>
-            <a:r>
-              <a:t>Feature Roadmap &amp; Improvements Summary</a:t>
-            </a:r>
-          </a:p>
-          <a:p>
-            <a:r>
-              <a:t>HarmonyOS NEXT Production-Ready Upgrade</a:t>
-            </a:r>
-          </a:p>
-        </p:txBody>
-      </p:sp>
-    </p:spTree>
-  </p:cSld>
-  <p:clrMapOvr>
-    <a:masterClrMapping/>
-  </p:clrMapOvr>
-</p:sld>
-</file>
-
-<file path=ppt/slides/slide2.xml><?xml version="1.0" encoding="utf-8"?>
-<p:sld xmlns:a="http://schemas.openxmlformats.org/drawingml/2006/main" xmlns:p="http://schemas.openxmlformats.org/presentationml/2006/main" xmlns:r="http://schemas.openxmlformats.org/officeDocument/2006/relationships">
-  <p:cSld>
-    <p:spTree>
-      <p:nvGrpSpPr>
-        <p:cNvPr id="1" name=""/>
-        <p:cNvGrpSpPr/>
-        <p:nvPr/>
-      </p:nvGrpSpPr>
-      <p:grpSpPr/>
-      <p:sp>
-        <p:nvSpPr>
-          <p:cNvPr id="2" name="Title 1"/>
-          <p:cNvSpPr>
-            <a:spLocks noGrp="1"/>
-          </p:cNvSpPr>
-          <p:nvPr>
             <p:ph type="title"/>
           </p:nvPr>
         </p:nvSpPr>
@@ -3177,7 +3104,7 @@
           <a:lstStyle/>
           <a:p>
             <a:r>
-              <a:t>Project Overview</a:t>
+              <a:t>Barista Recipes - Feature Implementation Summary</a:t>
             </a:r>
           </a:p>
         </p:txBody>
@@ -3194,541 +3121,115 @@
         </p:nvSpPr>
         <p:spPr/>
         <p:txBody>
-          <a:bodyPr/>
-          <a:lstStyle/>
-          <a:p>
-            <a:r>
-              <a:t>Transformation from a basic prototype to a feature-rich barista assistant.</a:t>
-            </a:r>
-          </a:p>
-          <a:p>
-            <a:r>
-              <a:t>• Full implementation of the 18-point improvement plan.</a:t>
-            </a:r>
-          </a:p>
-          <a:p>
-            <a:r>
-              <a:t>• Optimized for circular wearable displays (Huawei Watch 5).</a:t>
-            </a:r>
-          </a:p>
-          <a:p>
-            <a:r>
-              <a:t>• Strict ArkTS typing and robust error handling.</a:t>
-            </a:r>
-          </a:p>
-        </p:txBody>
-      </p:sp>
-    </p:spTree>
-  </p:cSld>
-  <p:clrMapOvr>
-    <a:masterClrMapping/>
-  </p:clrMapOvr>
-</p:sld>
-</file>
-
-<file path=ppt/slides/slide3.xml><?xml version="1.0" encoding="utf-8"?>
-<p:sld xmlns:a="http://schemas.openxmlformats.org/drawingml/2006/main" xmlns:p="http://schemas.openxmlformats.org/presentationml/2006/main" xmlns:r="http://schemas.openxmlformats.org/officeDocument/2006/relationships">
-  <p:cSld>
-    <p:spTree>
-      <p:nvGrpSpPr>
-        <p:cNvPr id="1" name=""/>
-        <p:cNvGrpSpPr/>
-        <p:nvPr/>
-      </p:nvGrpSpPr>
-      <p:grpSpPr/>
-      <p:sp>
-        <p:nvSpPr>
-          <p:cNvPr id="2" name="Title 1"/>
-          <p:cNvSpPr>
-            <a:spLocks noGrp="1"/>
-          </p:cNvSpPr>
-          <p:nvPr>
-            <p:ph type="title"/>
-          </p:nvPr>
-        </p:nvSpPr>
-        <p:spPr/>
-        <p:txBody>
-          <a:bodyPr/>
-          <a:lstStyle/>
-          <a:p>
-            <a:r>
-              <a:t>Data Architecture</a:t>
-            </a:r>
-          </a:p>
-        </p:txBody>
-      </p:sp>
-      <p:sp>
-        <p:nvSpPr>
-          <p:cNvPr id="3" name="Content Placeholder 2"/>
-          <p:cNvSpPr>
-            <a:spLocks noGrp="1"/>
-          </p:cNvSpPr>
-          <p:nvPr>
-            <p:ph idx="1"/>
-          </p:nvPr>
-        </p:nvSpPr>
-        <p:spPr/>
-        <p:txBody>
-          <a:bodyPr/>
-          <a:lstStyle/>
-          <a:p>
-            <a:r>
-              <a:t>Decoupled logic from UI using a centralized service layer.</a:t>
-            </a:r>
-          </a:p>
-          <a:p>
-            <a:r>
-              <a:t>• RecipeService: Singleton for managing 17 recipes.</a:t>
-            </a:r>
-          </a:p>
-          <a:p>
-            <a:r>
-              <a:t>• RecipeModel: Typed interfaces for ingredients and steps.</a:t>
-            </a:r>
-          </a:p>
-          <a:p>
-            <a:r>
-              <a:t>• Persistent Storage: Local Preferences for Favorites and History.</a:t>
-            </a:r>
-          </a:p>
-        </p:txBody>
-      </p:sp>
-    </p:spTree>
-  </p:cSld>
-  <p:clrMapOvr>
-    <a:masterClrMapping/>
-  </p:clrMapOvr>
-</p:sld>
-</file>
-
-<file path=ppt/slides/slide4.xml><?xml version="1.0" encoding="utf-8"?>
-<p:sld xmlns:a="http://schemas.openxmlformats.org/drawingml/2006/main" xmlns:p="http://schemas.openxmlformats.org/presentationml/2006/main" xmlns:r="http://schemas.openxmlformats.org/officeDocument/2006/relationships">
-  <p:cSld>
-    <p:spTree>
-      <p:nvGrpSpPr>
-        <p:cNvPr id="1" name=""/>
-        <p:cNvGrpSpPr/>
-        <p:nvPr/>
-      </p:nvGrpSpPr>
-      <p:grpSpPr/>
-      <p:sp>
-        <p:nvSpPr>
-          <p:cNvPr id="2" name="Title 1"/>
-          <p:cNvSpPr>
-            <a:spLocks noGrp="1"/>
-          </p:cNvSpPr>
-          <p:nvPr>
-            <p:ph type="title"/>
-          </p:nvPr>
-        </p:nvSpPr>
-        <p:spPr/>
-        <p:txBody>
-          <a:bodyPr/>
-          <a:lstStyle/>
-          <a:p>
-            <a:r>
-              <a:t>Expanded Recipe Content</a:t>
-            </a:r>
-          </a:p>
-        </p:txBody>
-      </p:sp>
-      <p:sp>
-        <p:nvSpPr>
-          <p:cNvPr id="3" name="Content Placeholder 2"/>
-          <p:cNvSpPr>
-            <a:spLocks noGrp="1"/>
-          </p:cNvSpPr>
-          <p:nvPr>
-            <p:ph idx="1"/>
-          </p:nvPr>
-        </p:nvSpPr>
-        <p:spPr/>
-        <p:txBody>
-          <a:bodyPr/>
-          <a:lstStyle/>
-          <a:p>
-            <a:r>
-              <a:t>Rich brewing guides for coffee and tea lovers.</a:t>
-            </a:r>
-          </a:p>
-          <a:p>
-            <a:r>
-              <a:t>• 17 Recipes across 5 Categories (Milk, Cold, Dairy-Free, Special, Tea).</a:t>
-            </a:r>
-          </a:p>
-          <a:p>
-            <a:r>
-              <a:t>• Detailed multi-step instructions (Grind, Pull, Froth, Layer, etc.).</a:t>
-            </a:r>
-          </a:p>
-          <a:p>
-            <a:r>
-              <a:t>• Specific ingredients and difficulty levels per recipe.</a:t>
-            </a:r>
-          </a:p>
-        </p:txBody>
-      </p:sp>
-    </p:spTree>
-  </p:cSld>
-  <p:clrMapOvr>
-    <a:masterClrMapping/>
-  </p:clrMapOvr>
-</p:sld>
-</file>
-
-<file path=ppt/slides/slide5.xml><?xml version="1.0" encoding="utf-8"?>
-<p:sld xmlns:a="http://schemas.openxmlformats.org/drawingml/2006/main" xmlns:p="http://schemas.openxmlformats.org/presentationml/2006/main" xmlns:r="http://schemas.openxmlformats.org/officeDocument/2006/relationships">
-  <p:cSld>
-    <p:spTree>
-      <p:nvGrpSpPr>
-        <p:cNvPr id="1" name=""/>
-        <p:cNvGrpSpPr/>
-        <p:nvPr/>
-      </p:nvGrpSpPr>
-      <p:grpSpPr/>
-      <p:sp>
-        <p:nvSpPr>
-          <p:cNvPr id="2" name="Title 1"/>
-          <p:cNvSpPr>
-            <a:spLocks noGrp="1"/>
-          </p:cNvSpPr>
-          <p:nvPr>
-            <p:ph type="title"/>
-          </p:nvPr>
-        </p:nvSpPr>
-        <p:spPr/>
-        <p:txBody>
-          <a:bodyPr/>
-          <a:lstStyle/>
-          <a:p>
-            <a:r>
-              <a:t>Interactive Experience</a:t>
-            </a:r>
-          </a:p>
-        </p:txBody>
-      </p:sp>
-      <p:sp>
-        <p:nvSpPr>
-          <p:cNvPr id="3" name="Content Placeholder 2"/>
-          <p:cNvSpPr>
-            <a:spLocks noGrp="1"/>
-          </p:cNvSpPr>
-          <p:nvPr>
-            <p:ph idx="1"/>
-          </p:nvPr>
-        </p:nvSpPr>
-        <p:spPr/>
-        <p:txBody>
-          <a:bodyPr/>
-          <a:lstStyle/>
-          <a:p>
-            <a:r>
-              <a:t>Leveraging wearable sensors for a better brew.</a:t>
-            </a:r>
-          </a:p>
-          <a:p>
-            <a:r>
-              <a:t>• Step Timers: Integrated countdowns for timed preparation steps.</a:t>
-            </a:r>
-          </a:p>
-          <a:p>
-            <a:r>
-              <a:t>• Haptic Feedback: Vibration patterns for timer completion.</a:t>
-            </a:r>
-          </a:p>
-          <a:p>
-            <a:r>
-              <a:t>• Accelerometer: Real-time 'Mixing Detection' by shaking device.</a:t>
-            </a:r>
-          </a:p>
-        </p:txBody>
-      </p:sp>
-    </p:spTree>
-  </p:cSld>
-  <p:clrMapOvr>
-    <a:masterClrMapping/>
-  </p:clrMapOvr>
-</p:sld>
-</file>
-
-<file path=ppt/slides/slide6.xml><?xml version="1.0" encoding="utf-8"?>
-<p:sld xmlns:a="http://schemas.openxmlformats.org/drawingml/2006/main" xmlns:p="http://schemas.openxmlformats.org/presentationml/2006/main" xmlns:r="http://schemas.openxmlformats.org/officeDocument/2006/relationships">
-  <p:cSld>
-    <p:spTree>
-      <p:nvGrpSpPr>
-        <p:cNvPr id="1" name=""/>
-        <p:cNvGrpSpPr/>
-        <p:nvPr/>
-      </p:nvGrpSpPr>
-      <p:grpSpPr/>
-      <p:sp>
-        <p:nvSpPr>
-          <p:cNvPr id="2" name="Title 1"/>
-          <p:cNvSpPr>
-            <a:spLocks noGrp="1"/>
-          </p:cNvSpPr>
-          <p:nvPr>
-            <p:ph type="title"/>
-          </p:nvPr>
-        </p:nvSpPr>
-        <p:spPr/>
-        <p:txBody>
-          <a:bodyPr/>
-          <a:lstStyle/>
-          <a:p>
-            <a:r>
-              <a:t>Wearable Optimized UI/UX</a:t>
-            </a:r>
-          </a:p>
-        </p:txBody>
-      </p:sp>
-      <p:sp>
-        <p:nvSpPr>
-          <p:cNvPr id="3" name="Content Placeholder 2"/>
-          <p:cNvSpPr>
-            <a:spLocks noGrp="1"/>
-          </p:cNvSpPr>
-          <p:nvPr>
-            <p:ph idx="1"/>
-          </p:nvPr>
-        </p:nvSpPr>
-        <p:spPr/>
-        <p:txBody>
-          <a:bodyPr/>
-          <a:lstStyle/>
-          <a:p>
-            <a:r>
-              <a:t>Circular-first design for readability and ease of use.</a:t>
-            </a:r>
-          </a:p>
-          <a:p>
-            <a:r>
-              <a:t>• Progress Ring: Visual timer and step completion tracking.</a:t>
-            </a:r>
-          </a:p>
-          <a:p>
-            <a:r>
-              <a:t>• Theming: Centralized Constants.ets for consistent palette.</a:t>
-            </a:r>
-          </a:p>
-          <a:p>
-            <a:r>
-              <a:t>• Minimalist Icons: 15+ Custom SVG icons for every recipe.</a:t>
-            </a:r>
-          </a:p>
-        </p:txBody>
-      </p:sp>
-    </p:spTree>
-  </p:cSld>
-  <p:clrMapOvr>
-    <a:masterClrMapping/>
-  </p:clrMapOvr>
-</p:sld>
-</file>
-
-<file path=ppt/slides/slide7.xml><?xml version="1.0" encoding="utf-8"?>
-<p:sld xmlns:a="http://schemas.openxmlformats.org/drawingml/2006/main" xmlns:p="http://schemas.openxmlformats.org/presentationml/2006/main" xmlns:r="http://schemas.openxmlformats.org/officeDocument/2006/relationships">
-  <p:cSld>
-    <p:spTree>
-      <p:nvGrpSpPr>
-        <p:cNvPr id="1" name=""/>
-        <p:cNvGrpSpPr/>
-        <p:nvPr/>
-      </p:nvGrpSpPr>
-      <p:grpSpPr/>
-      <p:sp>
-        <p:nvSpPr>
-          <p:cNvPr id="2" name="Title 1"/>
-          <p:cNvSpPr>
-            <a:spLocks noGrp="1"/>
-          </p:cNvSpPr>
-          <p:nvPr>
-            <p:ph type="title"/>
-          </p:nvPr>
-        </p:nvSpPr>
-        <p:spPr/>
-        <p:txBody>
-          <a:bodyPr/>
-          <a:lstStyle/>
-          <a:p>
-            <a:r>
-              <a:t>Navigation &amp; Usability</a:t>
-            </a:r>
-          </a:p>
-        </p:txBody>
-      </p:sp>
-      <p:sp>
-        <p:nvSpPr>
-          <p:cNvPr id="3" name="Content Placeholder 2"/>
-          <p:cNvSpPr>
-            <a:spLocks noGrp="1"/>
-          </p:cNvSpPr>
-          <p:nvPr>
-            <p:ph idx="1"/>
-          </p:nvPr>
-        </p:nvSpPr>
-        <p:spPr/>
-        <p:txBody>
-          <a:bodyPr/>
-          <a:lstStyle/>
-          <a:p>
-            <a:r>
-              <a:t>Seamless movement across the application.</a:t>
-            </a:r>
-          </a:p>
-          <a:p>
-            <a:r>
-              <a:t>• NavPathStack: Modern navigation architecture.</a:t>
-            </a:r>
-          </a:p>
-          <a:p>
-            <a:r>
-              <a:t>• BackButton: Re-engineered 40x40 circular button.</a:t>
-            </a:r>
-          </a:p>
-          <a:p>
-            <a:r>
-              <a:t>• Gestures: Added 'Swipe-right to go back' support.</a:t>
-            </a:r>
-          </a:p>
-        </p:txBody>
-      </p:sp>
-    </p:spTree>
-  </p:cSld>
-  <p:clrMapOvr>
-    <a:masterClrMapping/>
-  </p:clrMapOvr>
-</p:sld>
-</file>
-
-<file path=ppt/slides/slide8.xml><?xml version="1.0" encoding="utf-8"?>
-<p:sld xmlns:a="http://schemas.openxmlformats.org/drawingml/2006/main" xmlns:p="http://schemas.openxmlformats.org/presentationml/2006/main" xmlns:r="http://schemas.openxmlformats.org/officeDocument/2006/relationships">
-  <p:cSld>
-    <p:spTree>
-      <p:nvGrpSpPr>
-        <p:cNvPr id="1" name=""/>
-        <p:cNvGrpSpPr/>
-        <p:nvPr/>
-      </p:nvGrpSpPr>
-      <p:grpSpPr/>
-      <p:sp>
-        <p:nvSpPr>
-          <p:cNvPr id="2" name="Title 1"/>
-          <p:cNvSpPr>
-            <a:spLocks noGrp="1"/>
-          </p:cNvSpPr>
-          <p:nvPr>
-            <p:ph type="title"/>
-          </p:nvPr>
-        </p:nvSpPr>
-        <p:spPr/>
-        <p:txBody>
-          <a:bodyPr/>
-          <a:lstStyle/>
-          <a:p>
-            <a:r>
-              <a:t>Personalization</a:t>
-            </a:r>
-          </a:p>
-        </p:txBody>
-      </p:sp>
-      <p:sp>
-        <p:nvSpPr>
-          <p:cNvPr id="3" name="Content Placeholder 2"/>
-          <p:cNvSpPr>
-            <a:spLocks noGrp="1"/>
-          </p:cNvSpPr>
-          <p:nvPr>
-            <p:ph idx="1"/>
-          </p:nvPr>
-        </p:nvSpPr>
-        <p:spPr/>
-        <p:txBody>
-          <a:bodyPr/>
-          <a:lstStyle/>
-          <a:p>
-            <a:r>
-              <a:t>Keeping track of preferences and habits.</a:t>
-            </a:r>
-          </a:p>
-          <a:p>
-            <a:r>
-              <a:t>• Favorites: Quick access to bookmarked coffee recipes.</a:t>
-            </a:r>
-          </a:p>
-          <a:p>
-            <a:r>
-              <a:t>• Brew History: Log of the last 20 brewing sessions.</a:t>
-            </a:r>
-          </a:p>
-        </p:txBody>
-      </p:sp>
-    </p:spTree>
-  </p:cSld>
-  <p:clrMapOvr>
-    <a:masterClrMapping/>
-  </p:clrMapOvr>
-</p:sld>
-</file>
-
-<file path=ppt/slides/slide9.xml><?xml version="1.0" encoding="utf-8"?>
-<p:sld xmlns:a="http://schemas.openxmlformats.org/drawingml/2006/main" xmlns:p="http://schemas.openxmlformats.org/presentationml/2006/main" xmlns:r="http://schemas.openxmlformats.org/officeDocument/2006/relationships">
-  <p:cSld>
-    <p:spTree>
-      <p:nvGrpSpPr>
-        <p:cNvPr id="1" name=""/>
-        <p:cNvGrpSpPr/>
-        <p:nvPr/>
-      </p:nvGrpSpPr>
-      <p:grpSpPr/>
-      <p:sp>
-        <p:nvSpPr>
-          <p:cNvPr id="2" name="Title 1"/>
-          <p:cNvSpPr>
-            <a:spLocks noGrp="1"/>
-          </p:cNvSpPr>
-          <p:nvPr>
-            <p:ph type="title"/>
-          </p:nvPr>
-        </p:nvSpPr>
-        <p:spPr/>
-        <p:txBody>
-          <a:bodyPr/>
-          <a:lstStyle/>
-          <a:p>
-            <a:r>
-              <a:t>Conclusion</a:t>
-            </a:r>
-          </a:p>
-        </p:txBody>
-      </p:sp>
-      <p:sp>
-        <p:nvSpPr>
-          <p:cNvPr id="3" name="Content Placeholder 2"/>
-          <p:cNvSpPr>
-            <a:spLocks noGrp="1"/>
-          </p:cNvSpPr>
-          <p:nvPr>
-            <p:ph idx="1"/>
-          </p:nvPr>
-        </p:nvSpPr>
-        <p:spPr/>
-        <p:txBody>
-          <a:bodyPr/>
-          <a:lstStyle/>
-          <a:p>
-            <a:r>
-              <a:t>The Barista Recipes app is now production-ready.</a:t>
-            </a:r>
-          </a:p>
-          <a:p>
-            <a:r>
-              <a:t>• Stable, strictly typed ArkTS codebase.</a:t>
-            </a:r>
-          </a:p>
-          <a:p>
-            <a:r>
-              <a:t>• Engaging, interactive, and data-driven user experience.</a:t>
+          <a:bodyPr wrap="square"/>
+          <a:lstStyle/>
+          <a:p>
+            <a:r>
+              <a:t>Recipe Data Model &amp; Dynamic Service Layer (17 Recipes)</a:t>
+            </a:r>
+          </a:p>
+          <a:p>
+            <a:pPr>
+              <a:defRPr sz="1400"/>
+            </a:pPr>
+            <a:r>
+              <a:t>• Local Persistence via Preferences (Favorites &amp; History)</a:t>
+            </a:r>
+          </a:p>
+          <a:p>
+            <a:pPr>
+              <a:defRPr sz="1400"/>
+            </a:pPr>
+            <a:r>
+              <a:t>• Detailed Ingredients &amp; Multi-step Brewing Instructions</a:t>
+            </a:r>
+          </a:p>
+          <a:p>
+            <a:pPr>
+              <a:defRPr sz="1400"/>
+            </a:pPr>
+            <a:r>
+              <a:t>• Interactive Step Timer with Dynamic Progress Ring</a:t>
+            </a:r>
+          </a:p>
+          <a:p>
+            <a:pPr>
+              <a:defRPr sz="1400"/>
+            </a:pPr>
+            <a:r>
+              <a:t>• Haptic Feedback (Vibration) for Timers and Transitions</a:t>
+            </a:r>
+          </a:p>
+          <a:p>
+            <a:pPr>
+              <a:defRPr sz="1400"/>
+            </a:pPr>
+            <a:r>
+              <a:t>• Accelerometer-based 'Mixing Detection' via Shaking</a:t>
+            </a:r>
+          </a:p>
+          <a:p>
+            <a:pPr>
+              <a:defRPr sz="1400"/>
+            </a:pPr>
+            <a:r>
+              <a:t>• Wearable-Optimized UI (Circular Layout, Large Fonts)</a:t>
+            </a:r>
+          </a:p>
+          <a:p>
+            <a:pPr>
+              <a:defRPr sz="1400"/>
+            </a:pPr>
+            <a:r>
+              <a:t>• Enhanced Navigation (BackButton, Swipe-right to Back)</a:t>
+            </a:r>
+          </a:p>
+          <a:p>
+            <a:pPr>
+              <a:defRPr sz="1400"/>
+            </a:pPr>
+            <a:r>
+              <a:t>• Custom Minimalist SVG Icons for all Coffee &amp; Tea types</a:t>
+            </a:r>
+          </a:p>
+          <a:p>
+            <a:pPr>
+              <a:defRPr sz="1400"/>
+            </a:pPr>
+            <a:r>
+              <a:t>• Favorites Toggling &amp; Brew History Tracker (Last 20)</a:t>
+            </a:r>
+          </a:p>
+          <a:p>
+            <a:pPr>
+              <a:defRPr sz="1400"/>
+            </a:pPr>
+            <a:r>
+              <a:t>• Difficulty &amp; Brew Time Metadata for every recipe</a:t>
+            </a:r>
+          </a:p>
+          <a:p>
+            <a:pPr>
+              <a:defRPr sz="1400"/>
+            </a:pPr>
+            <a:r>
+              <a:t>• Centralized Theming (Constants.ets) &amp; Error Handling</a:t>
+            </a:r>
+          </a:p>
+          <a:p>
+            <a:pPr>
+              <a:defRPr sz="1400"/>
+            </a:pPr>
+            <a:r>
+              <a:t>• Strict ArkTS Strict-Typing &amp; Architecture Compliance</a:t>
+            </a:r>
+          </a:p>
+          <a:p>
+            <a:pPr>
+              <a:defRPr sz="1400"/>
+            </a:pPr>
+            <a:r>
+              <a:t>• Voice Command Boilerplate for Future Expansion</a:t>
             </a:r>
           </a:p>
         </p:txBody>

</xml_diff>

<commit_message>
feat: resize and reposition BackButton for better UI layout
- Reduced BackButton size to 32x32 and font size to 16
- Adjusted BackButton margin to top: 20, left: 20 across all pages
- Updated PowerPoint summary to reflect latest UI refinements
- Finalized all production-ready improvements and fixes
</commit_message>
<xml_diff>
--- a/Barista_Recipes_Improvements.pptx
+++ b/Barista_Recipes_Improvements.pptx
@@ -3173,7 +3173,7 @@
               <a:defRPr sz="1400"/>
             </a:pPr>
             <a:r>
-              <a:t>• Wearable-Optimized UI (Circular Layout, Large Fonts)</a:t>
+              <a:t>• Wearable-Optimized UI (Circular Layout, Swipe-to-Back)</a:t>
             </a:r>
           </a:p>
           <a:p>
@@ -3181,7 +3181,7 @@
               <a:defRPr sz="1400"/>
             </a:pPr>
             <a:r>
-              <a:t>• Enhanced Navigation (BackButton, Swipe-right to Back)</a:t>
+              <a:t>• Refined Navigation (Small, Top-positioned BackButton)</a:t>
             </a:r>
           </a:p>
           <a:p>

</xml_diff>